<commit_message>
feat: UART1 link at 921600 baud with receiver-driven flow control
- edhoc_transport.c: the receiver sends a READY byte every 0.2 ms while
  it waits for a frame; the sender drops stale READYs, waits for a fresh
  one and sends the frame at line rate. Replaces the per-byte pacing and
  the 2 s app-level settle wait.
- UART1_BAUD (default 921600) shared by both packages.
- Measured (TBD3): handshake 0.77 s, 256 KiB at 49.5 KB/s, 1 MiB SD card
  to SD card in 32.2 s (radio: 99.6 s).
- Slides: setup illustration on the Digilent board photo, labelled
  PMOD sockets, wired-link results slide; README transport note.
</commit_message>
<xml_diff>
--- a/fpga/sw/export/docs/slides/05_Secure_file_transfer_and_results.pptx
+++ b/fpga/sw/export/docs/slides/05_Secure_file_transfer_and_results.pptx
@@ -60,6 +60,7 @@
     <p:sldId id="917" r:id="rId64"/>
     <p:sldId id="918" r:id="rId65"/>
     <p:sldId id="919" r:id="rId66"/>
+    <p:sldId id="920" r:id="rId67"/>
   </p:sldIdLst>
   <p:sldSz cx="12192000" cy="6858000"/>
   <p:notesSz cx="7559675" cy="10691813"/>
@@ -27685,7 +27686,7 @@
                 <a:latin typeface="Times New Roman" panose="02020603050405020304" pitchFamily="18" charset="0"/>
                 <a:cs typeface="Times New Roman" panose="02020603050405020304" pitchFamily="18" charset="0"/>
               </a:rPr>
-              <a:t>(1/6) Measure first</a:t>
+              <a:t>(1/7) Measure first</a:t>
             </a:r>
           </a:p>
         </p:txBody>
@@ -28344,7 +28345,7 @@
                 <a:latin typeface="Times New Roman" panose="02020603050405020304" pitchFamily="18" charset="0"/>
                 <a:cs typeface="Times New Roman" panose="02020603050405020304" pitchFamily="18" charset="0"/>
               </a:rPr>
-              <a:t>(2/6) The multiply trap</a:t>
+              <a:t>(2/7) The multiply trap</a:t>
             </a:r>
           </a:p>
         </p:txBody>
@@ -28847,7 +28848,7 @@
                 <a:latin typeface="Times New Roman" panose="02020603050405020304" pitchFamily="18" charset="0"/>
                 <a:cs typeface="Times New Roman" panose="02020603050405020304" pitchFamily="18" charset="0"/>
               </a:rPr>
-              <a:t>(3/6) Table-based AES</a:t>
+              <a:t>(3/7) Table-based AES</a:t>
             </a:r>
           </a:p>
         </p:txBody>
@@ -29552,7 +29553,7 @@
                 <a:latin typeface="Times New Roman" panose="02020603050405020304" pitchFamily="18" charset="0"/>
                 <a:cs typeface="Times New Roman" panose="02020603050405020304" pitchFamily="18" charset="0"/>
               </a:rPr>
-              <a:t>(4/6) The radio side</a:t>
+              <a:t>(4/7) The radio side</a:t>
             </a:r>
           </a:p>
         </p:txBody>
@@ -30244,7 +30245,7 @@
                 <a:latin typeface="Times New Roman" panose="02020603050405020304" pitchFamily="18" charset="0"/>
                 <a:cs typeface="Times New Roman" panose="02020603050405020304" pitchFamily="18" charset="0"/>
               </a:rPr>
-              <a:t>(5/6) Result</a:t>
+              <a:t>(5/7) Result</a:t>
             </a:r>
           </a:p>
         </p:txBody>
@@ -30753,7 +30754,7 @@
                 </a:solidFill>
                 <a:latin typeface="Times New Roman"/>
               </a:rPr>
-              <a:t>Check yourself: a TIMING=1 build prints PERF encrypt / decrypt in B/s; compare with the micro-benchmark of (1/6).</a:t>
+              <a:t>Check yourself: a TIMING=1 build prints PERF encrypt / decrypt in B/s; compare with the micro-benchmark of (1/7).</a:t>
             </a:r>
           </a:p>
         </p:txBody>
@@ -30844,7 +30845,7 @@
                 <a:latin typeface="Times New Roman" panose="02020603050405020304" pitchFamily="18" charset="0"/>
                 <a:cs typeface="Times New Roman" panose="02020603050405020304" pitchFamily="18" charset="0"/>
               </a:rPr>
-              <a:t>(6/6) Where the limit is now</a:t>
+              <a:t>(6/7) Where the limit is now</a:t>
             </a:r>
           </a:p>
         </p:txBody>
@@ -31175,25 +31176,7 @@
                 </a:solidFill>
                 <a:latin typeface="Times New Roman"/>
               </a:rPr>
-              <a:t>The wired UART link on PMOD JB (TRANSPORT=uart) is </a:t>
-            </a:r>
-            <a:r>
-              <a:rPr sz="1800" b="1">
-                <a:solidFill>
-                  <a:srgbClr val="000000"/>
-                </a:solidFill>
-                <a:latin typeface="Times New Roman"/>
-              </a:rPr>
-              <a:t>slower</a:t>
-            </a:r>
-            <a:r>
-              <a:rPr sz="1800" b="0">
-                <a:solidFill>
-                  <a:srgbClr val="000000"/>
-                </a:solidFill>
-                <a:latin typeface="Times New Roman"/>
-              </a:rPr>
-              <a:t>, measured 2.4 KB/s: the receiver polls UART1 without a usable FIFO, so the sender waits after every byte. Faster needs buffered hardware (FIFO + interrupts, or DMA).</a:t>
+              <a:t>Faster needs a faster link: three wires between the PMOD JB ports give 3× the radio's speed (next slide).</a:t>
             </a:r>
           </a:p>
         </p:txBody>
@@ -31207,6 +31190,706 @@
 </file>
 
 <file path=ppt/slides/slide49.xml><?xml version="1.0" encoding="utf-8"?>
+<p:sld xmlns:a="http://schemas.openxmlformats.org/drawingml/2006/main" xmlns:p="http://schemas.openxmlformats.org/presentationml/2006/main" xmlns:r="http://schemas.openxmlformats.org/officeDocument/2006/relationships">
+  <p:cSld>
+    <p:spTree>
+      <p:nvGrpSpPr>
+        <p:cNvPr id="1" name=""/>
+        <p:cNvGrpSpPr/>
+        <p:nvPr/>
+      </p:nvGrpSpPr>
+      <p:grpSpPr/>
+      <p:sp>
+        <p:nvSpPr>
+          <p:cNvPr id="10" name="CustomShape 6">
+            <a:extLst>
+              <a:ext uri="{FF2B5EF4-FFF2-40B4-BE49-F238E27FC236}">
+                <a16:creationId xmlns:a16="http://schemas.microsoft.com/office/drawing/2014/main" id="{CB76DC60-C0C9-436D-8956-EE4CA394869E}"/>
+              </a:ext>
+            </a:extLst>
+          </p:cNvPr>
+          <p:cNvSpPr/>
+          <p:nvPr/>
+        </p:nvSpPr>
+        <p:spPr>
+          <a:xfrm>
+            <a:off x="-6000" y="0"/>
+            <a:ext cx="12198000" cy="644877"/>
+          </a:xfrm>
+          <a:prstGeom prst="rect">
+            <a:avLst/>
+          </a:prstGeom>
+          <a:solidFill>
+            <a:schemeClr val="accent6">
+              <a:lumMod val="40000"/>
+              <a:lumOff val="60000"/>
+            </a:schemeClr>
+          </a:solidFill>
+          <a:ln>
+            <a:noFill/>
+          </a:ln>
+        </p:spPr>
+        <p:style>
+          <a:lnRef idx="0">
+            <a:scrgbClr r="0" g="0" b="0"/>
+          </a:lnRef>
+          <a:fillRef idx="0">
+            <a:scrgbClr r="0" g="0" b="0"/>
+          </a:fillRef>
+          <a:effectRef idx="0">
+            <a:scrgbClr r="0" g="0" b="0"/>
+          </a:effectRef>
+          <a:fontRef idx="minor"/>
+        </p:style>
+        <p:txBody>
+          <a:bodyPr wrap="square" lIns="90000" tIns="45000" rIns="90000" bIns="45000">
+            <a:spAutoFit/>
+          </a:bodyPr>
+          <a:lstStyle/>
+          <a:p>
+            <a:pPr marL="360" algn="ctr">
+              <a:lnSpc>
+                <a:spcPct val="100000"/>
+              </a:lnSpc>
+              <a:buClr>
+                <a:srgbClr val="000000"/>
+              </a:buClr>
+            </a:pPr>
+            <a:r>
+              <a:rPr lang="en-US" sz="3000" b="1" spc="-1" dirty="0">
+                <a:latin typeface="Times New Roman" panose="02020603050405020304" pitchFamily="18" charset="0"/>
+                <a:cs typeface="Times New Roman" panose="02020603050405020304" pitchFamily="18" charset="0"/>
+              </a:rPr>
+              <a:t>5. Making It Faster </a:t>
+            </a:r>
+            <a:r>
+              <a:rPr lang="en-US" sz="3000" spc="-1" dirty="0">
+                <a:latin typeface="Times New Roman" panose="02020603050405020304" pitchFamily="18" charset="0"/>
+                <a:cs typeface="Times New Roman" panose="02020603050405020304" pitchFamily="18" charset="0"/>
+              </a:rPr>
+              <a:t>(7/7) A wired link: UART1 at 921,600 baud</a:t>
+            </a:r>
+          </a:p>
+        </p:txBody>
+      </p:sp>
+      <p:sp>
+        <p:nvSpPr>
+          <p:cNvPr id="62" name="CustomShape 2"/>
+          <p:cNvSpPr/>
+          <p:nvPr/>
+        </p:nvSpPr>
+        <p:spPr>
+          <a:xfrm>
+            <a:off x="11291400" y="6492960"/>
+            <a:ext cx="894600" cy="358920"/>
+          </a:xfrm>
+          <a:prstGeom prst="rect">
+            <a:avLst/>
+          </a:prstGeom>
+          <a:noFill/>
+          <a:ln>
+            <a:noFill/>
+          </a:ln>
+        </p:spPr>
+        <p:style>
+          <a:lnRef idx="0">
+            <a:scrgbClr r="0" g="0" b="0"/>
+          </a:lnRef>
+          <a:fillRef idx="0">
+            <a:scrgbClr r="0" g="0" b="0"/>
+          </a:fillRef>
+          <a:effectRef idx="0">
+            <a:scrgbClr r="0" g="0" b="0"/>
+          </a:effectRef>
+          <a:fontRef idx="minor"/>
+        </p:style>
+        <p:txBody>
+          <a:bodyPr lIns="90000" tIns="45000" rIns="90000" bIns="45000" anchor="ctr">
+            <a:noAutofit/>
+          </a:bodyPr>
+          <a:lstStyle/>
+          <a:p>
+            <a:pPr algn="ctr">
+              <a:lnSpc>
+                <a:spcPct val="100000"/>
+              </a:lnSpc>
+            </a:pPr>
+            <a:fld id="{32452110-F6D1-439F-92C4-7A3912DA20B0}" type="slidenum">
+              <a:rPr lang="en-US" sz="1600" b="1" strike="noStrike" spc="-1">
+                <a:solidFill>
+                  <a:srgbClr val="000000"/>
+                </a:solidFill>
+                <a:latin typeface="Times New Roman"/>
+                <a:ea typeface="DejaVu Sans"/>
+              </a:rPr>
+              <a:t>43</a:t>
+            </a:fld>
+            <a:endParaRPr lang="en-US" sz="1600" b="0" strike="noStrike" spc="-1">
+              <a:latin typeface="Arial"/>
+            </a:endParaRPr>
+          </a:p>
+        </p:txBody>
+      </p:sp>
+      <p:graphicFrame>
+        <p:nvGraphicFramePr>
+          <p:cNvPr id="63" name="Table 62"/>
+          <p:cNvGraphicFramePr>
+            <a:graphicFrameLocks noGrp="1"/>
+          </p:cNvGraphicFramePr>
+          <p:nvPr/>
+        </p:nvGraphicFramePr>
+        <p:xfrm>
+          <a:off x="365760" y="868680"/>
+          <a:ext cx="11430000" cy="2011680"/>
+        </p:xfrm>
+        <a:graphic>
+          <a:graphicData uri="http://schemas.openxmlformats.org/drawingml/2006/table">
+            <a:tbl>
+              <a:tblPr firstRow="1" bandRow="1">
+                <a:tableStyleId>{5C22544A-7EE6-4342-B048-85BDC9FD1C3A}</a:tableStyleId>
+              </a:tblPr>
+              <a:tblGrid>
+                <a:gridCol w="3291840"/>
+                <a:gridCol w="2377440"/>
+                <a:gridCol w="2834640"/>
+                <a:gridCol w="2926080"/>
+              </a:tblGrid>
+              <a:tr h="502920">
+                <a:tc>
+                  <a:txBody>
+                    <a:bodyPr wrap="square"/>
+                    <a:lstStyle/>
+                    <a:p>
+                      <a:r>
+                        <a:rPr sz="1500" b="1">
+                          <a:solidFill>
+                            <a:srgbClr val="000000"/>
+                          </a:solidFill>
+                          <a:latin typeface="Times New Roman"/>
+                        </a:rPr>
+                        <a:t>TBD3, measured on the boards</a:t>
+                      </a:r>
+                    </a:p>
+                  </a:txBody>
+                  <a:tcPr marL="54864" marR="54864" marT="27432" marB="27432">
+                    <a:solidFill>
+                      <a:srgbClr val="C5E0B4"/>
+                    </a:solidFill>
+                  </a:tcPr>
+                </a:tc>
+                <a:tc>
+                  <a:txBody>
+                    <a:bodyPr wrap="square"/>
+                    <a:lstStyle/>
+                    <a:p>
+                      <a:r>
+                        <a:rPr sz="1500" b="1">
+                          <a:solidFill>
+                            <a:srgbClr val="000000"/>
+                          </a:solidFill>
+                          <a:latin typeface="Times New Roman"/>
+                        </a:rPr>
+                        <a:t>Radio (MRF24J40)</a:t>
+                      </a:r>
+                    </a:p>
+                  </a:txBody>
+                  <a:tcPr marL="54864" marR="54864" marT="27432" marB="27432">
+                    <a:solidFill>
+                      <a:srgbClr val="C5E0B4"/>
+                    </a:solidFill>
+                  </a:tcPr>
+                </a:tc>
+                <a:tc>
+                  <a:txBody>
+                    <a:bodyPr wrap="square"/>
+                    <a:lstStyle/>
+                    <a:p>
+                      <a:r>
+                        <a:rPr sz="1500" b="1">
+                          <a:solidFill>
+                            <a:srgbClr val="000000"/>
+                          </a:solidFill>
+                          <a:latin typeface="Times New Roman"/>
+                        </a:rPr>
+                        <a:t>UART, 57,600 baud, byte pacing</a:t>
+                      </a:r>
+                    </a:p>
+                  </a:txBody>
+                  <a:tcPr marL="54864" marR="54864" marT="27432" marB="27432">
+                    <a:solidFill>
+                      <a:srgbClr val="C5E0B4"/>
+                    </a:solidFill>
+                  </a:tcPr>
+                </a:tc>
+                <a:tc>
+                  <a:txBody>
+                    <a:bodyPr wrap="square"/>
+                    <a:lstStyle/>
+                    <a:p>
+                      <a:r>
+                        <a:rPr sz="1500" b="1">
+                          <a:solidFill>
+                            <a:srgbClr val="000000"/>
+                          </a:solidFill>
+                          <a:latin typeface="Times New Roman"/>
+                        </a:rPr>
+                        <a:t>UART, 921,600 baud, flow control</a:t>
+                      </a:r>
+                    </a:p>
+                  </a:txBody>
+                  <a:tcPr marL="54864" marR="54864" marT="27432" marB="27432">
+                    <a:solidFill>
+                      <a:srgbClr val="C5E0B4"/>
+                    </a:solidFill>
+                  </a:tcPr>
+                </a:tc>
+              </a:tr>
+              <a:tr h="502920">
+                <a:tc>
+                  <a:txBody>
+                    <a:bodyPr wrap="square"/>
+                    <a:lstStyle/>
+                    <a:p>
+                      <a:r>
+                        <a:rPr sz="1500" b="0">
+                          <a:solidFill>
+                            <a:srgbClr val="000000"/>
+                          </a:solidFill>
+                          <a:latin typeface="Times New Roman"/>
+                        </a:rPr>
+                        <a:t>Handshake</a:t>
+                      </a:r>
+                    </a:p>
+                  </a:txBody>
+                  <a:tcPr marL="54864" marR="54864" marT="27432" marB="27432">
+                    <a:solidFill>
+                      <a:srgbClr val="FFFFFF"/>
+                    </a:solidFill>
+                  </a:tcPr>
+                </a:tc>
+                <a:tc>
+                  <a:txBody>
+                    <a:bodyPr wrap="square"/>
+                    <a:lstStyle/>
+                    <a:p>
+                      <a:r>
+                        <a:rPr sz="1500" b="0">
+                          <a:solidFill>
+                            <a:srgbClr val="000000"/>
+                          </a:solidFill>
+                          <a:latin typeface="Times New Roman"/>
+                        </a:rPr>
+                        <a:t>1.25 s</a:t>
+                      </a:r>
+                    </a:p>
+                  </a:txBody>
+                  <a:tcPr marL="54864" marR="54864" marT="27432" marB="27432">
+                    <a:solidFill>
+                      <a:srgbClr val="FFFFFF"/>
+                    </a:solidFill>
+                  </a:tcPr>
+                </a:tc>
+                <a:tc>
+                  <a:txBody>
+                    <a:bodyPr wrap="square"/>
+                    <a:lstStyle/>
+                    <a:p>
+                      <a:r>
+                        <a:rPr sz="1500" b="0">
+                          <a:solidFill>
+                            <a:srgbClr val="000000"/>
+                          </a:solidFill>
+                          <a:latin typeface="Times New Roman"/>
+                        </a:rPr>
+                        <a:t>3.07 s</a:t>
+                      </a:r>
+                    </a:p>
+                  </a:txBody>
+                  <a:tcPr marL="54864" marR="54864" marT="27432" marB="27432">
+                    <a:solidFill>
+                      <a:srgbClr val="FFFFFF"/>
+                    </a:solidFill>
+                  </a:tcPr>
+                </a:tc>
+                <a:tc>
+                  <a:txBody>
+                    <a:bodyPr wrap="square"/>
+                    <a:lstStyle/>
+                    <a:p>
+                      <a:r>
+                        <a:rPr sz="1500" b="0">
+                          <a:solidFill>
+                            <a:srgbClr val="000000"/>
+                          </a:solidFill>
+                          <a:latin typeface="Times New Roman"/>
+                        </a:rPr>
+                        <a:t>0.77 s</a:t>
+                      </a:r>
+                    </a:p>
+                  </a:txBody>
+                  <a:tcPr marL="54864" marR="54864" marT="27432" marB="27432">
+                    <a:solidFill>
+                      <a:srgbClr val="FFFFFF"/>
+                    </a:solidFill>
+                  </a:tcPr>
+                </a:tc>
+              </a:tr>
+              <a:tr h="502920">
+                <a:tc>
+                  <a:txBody>
+                    <a:bodyPr wrap="square"/>
+                    <a:lstStyle/>
+                    <a:p>
+                      <a:r>
+                        <a:rPr sz="1500" b="0">
+                          <a:solidFill>
+                            <a:srgbClr val="000000"/>
+                          </a:solidFill>
+                          <a:latin typeface="Times New Roman"/>
+                        </a:rPr>
+                        <a:t>256 KiB generated data</a:t>
+                      </a:r>
+                    </a:p>
+                  </a:txBody>
+                  <a:tcPr marL="54864" marR="54864" marT="27432" marB="27432">
+                    <a:solidFill>
+                      <a:srgbClr val="F2F8EE"/>
+                    </a:solidFill>
+                  </a:tcPr>
+                </a:tc>
+                <a:tc>
+                  <a:txBody>
+                    <a:bodyPr wrap="square"/>
+                    <a:lstStyle/>
+                    <a:p>
+                      <a:r>
+                        <a:rPr sz="1500" b="0">
+                          <a:solidFill>
+                            <a:srgbClr val="000000"/>
+                          </a:solidFill>
+                          <a:latin typeface="Times New Roman"/>
+                        </a:rPr>
+                        <a:t>—</a:t>
+                      </a:r>
+                    </a:p>
+                  </a:txBody>
+                  <a:tcPr marL="54864" marR="54864" marT="27432" marB="27432">
+                    <a:solidFill>
+                      <a:srgbClr val="F2F8EE"/>
+                    </a:solidFill>
+                  </a:tcPr>
+                </a:tc>
+                <a:tc>
+                  <a:txBody>
+                    <a:bodyPr wrap="square"/>
+                    <a:lstStyle/>
+                    <a:p>
+                      <a:r>
+                        <a:rPr sz="1500" b="0">
+                          <a:solidFill>
+                            <a:srgbClr val="000000"/>
+                          </a:solidFill>
+                          <a:latin typeface="Times New Roman"/>
+                        </a:rPr>
+                        <a:t>2.4 KB/s</a:t>
+                      </a:r>
+                    </a:p>
+                  </a:txBody>
+                  <a:tcPr marL="54864" marR="54864" marT="27432" marB="27432">
+                    <a:solidFill>
+                      <a:srgbClr val="F2F8EE"/>
+                    </a:solidFill>
+                  </a:tcPr>
+                </a:tc>
+                <a:tc>
+                  <a:txBody>
+                    <a:bodyPr wrap="square"/>
+                    <a:lstStyle/>
+                    <a:p>
+                      <a:r>
+                        <a:rPr sz="1500" b="0">
+                          <a:solidFill>
+                            <a:srgbClr val="000000"/>
+                          </a:solidFill>
+                          <a:latin typeface="Times New Roman"/>
+                        </a:rPr>
+                        <a:t>49.5 KB/s</a:t>
+                      </a:r>
+                    </a:p>
+                  </a:txBody>
+                  <a:tcPr marL="54864" marR="54864" marT="27432" marB="27432">
+                    <a:solidFill>
+                      <a:srgbClr val="F2F8EE"/>
+                    </a:solidFill>
+                  </a:tcPr>
+                </a:tc>
+              </a:tr>
+              <a:tr h="502920">
+                <a:tc>
+                  <a:txBody>
+                    <a:bodyPr wrap="square"/>
+                    <a:lstStyle/>
+                    <a:p>
+                      <a:r>
+                        <a:rPr sz="1500" b="0">
+                          <a:solidFill>
+                            <a:srgbClr val="000000"/>
+                          </a:solidFill>
+                          <a:latin typeface="Times New Roman"/>
+                        </a:rPr>
+                        <a:t>1 MiB, SD card A → SD card B</a:t>
+                      </a:r>
+                    </a:p>
+                  </a:txBody>
+                  <a:tcPr marL="54864" marR="54864" marT="27432" marB="27432">
+                    <a:solidFill>
+                      <a:srgbClr val="FFFFFF"/>
+                    </a:solidFill>
+                  </a:tcPr>
+                </a:tc>
+                <a:tc>
+                  <a:txBody>
+                    <a:bodyPr wrap="square"/>
+                    <a:lstStyle/>
+                    <a:p>
+                      <a:r>
+                        <a:rPr sz="1500" b="0">
+                          <a:solidFill>
+                            <a:srgbClr val="000000"/>
+                          </a:solidFill>
+                          <a:latin typeface="Times New Roman"/>
+                        </a:rPr>
+                        <a:t>99.6 s (10.5 KB/s)</a:t>
+                      </a:r>
+                    </a:p>
+                  </a:txBody>
+                  <a:tcPr marL="54864" marR="54864" marT="27432" marB="27432">
+                    <a:solidFill>
+                      <a:srgbClr val="FFFFFF"/>
+                    </a:solidFill>
+                  </a:tcPr>
+                </a:tc>
+                <a:tc>
+                  <a:txBody>
+                    <a:bodyPr wrap="square"/>
+                    <a:lstStyle/>
+                    <a:p>
+                      <a:r>
+                        <a:rPr sz="1500" b="0">
+                          <a:solidFill>
+                            <a:srgbClr val="000000"/>
+                          </a:solidFill>
+                          <a:latin typeface="Times New Roman"/>
+                        </a:rPr>
+                        <a:t>—</a:t>
+                      </a:r>
+                    </a:p>
+                  </a:txBody>
+                  <a:tcPr marL="54864" marR="54864" marT="27432" marB="27432">
+                    <a:solidFill>
+                      <a:srgbClr val="FFFFFF"/>
+                    </a:solidFill>
+                  </a:tcPr>
+                </a:tc>
+                <a:tc>
+                  <a:txBody>
+                    <a:bodyPr wrap="square"/>
+                    <a:lstStyle/>
+                    <a:p>
+                      <a:r>
+                        <a:rPr sz="1500" b="0">
+                          <a:solidFill>
+                            <a:srgbClr val="000000"/>
+                          </a:solidFill>
+                          <a:latin typeface="Times New Roman"/>
+                        </a:rPr>
+                        <a:t>32.2 s (32.6 KB/s)</a:t>
+                      </a:r>
+                    </a:p>
+                  </a:txBody>
+                  <a:tcPr marL="54864" marR="54864" marT="27432" marB="27432">
+                    <a:solidFill>
+                      <a:srgbClr val="FFFFFF"/>
+                    </a:solidFill>
+                  </a:tcPr>
+                </a:tc>
+              </a:tr>
+            </a:tbl>
+          </a:graphicData>
+        </a:graphic>
+      </p:graphicFrame>
+      <p:sp>
+        <p:nvSpPr>
+          <p:cNvPr id="64" name="TextBox 63"/>
+          <p:cNvSpPr txBox="1"/>
+          <p:nvPr/>
+        </p:nvSpPr>
+        <p:spPr>
+          <a:xfrm>
+            <a:off x="365760" y="3108960"/>
+            <a:ext cx="11430000" cy="3200400"/>
+          </a:xfrm>
+          <a:prstGeom prst="rect">
+            <a:avLst/>
+          </a:prstGeom>
+          <a:noFill/>
+        </p:spPr>
+        <p:txBody>
+          <a:bodyPr wrap="square" anchor="t">
+            <a:spAutoFit/>
+          </a:bodyPr>
+          <a:lstStyle/>
+          <a:p>
+            <a:pPr marL="256032" indent="-219456">
+              <a:spcAft>
+                <a:spcPts val="400"/>
+              </a:spcAft>
+              <a:buChar char="•"/>
+            </a:pPr>
+            <a:r>
+              <a:rPr sz="1600" b="0">
+                <a:solidFill>
+                  <a:srgbClr val="000000"/>
+                </a:solidFill>
+                <a:latin typeface="Times New Roman"/>
+              </a:rPr>
+              <a:t>Wiring: A's JB2 (TX) → B's JB1 (RX), B's JB2 (TX) → A's JB1 (RX), JB5 GND ↔ JB5 GND (Lesson 1, section 4). Build both images with </a:t>
+            </a:r>
+            <a:r>
+              <a:rPr sz="1400" b="0">
+                <a:solidFill>
+                  <a:srgbClr val="8B1A1A"/>
+                </a:solidFill>
+                <a:latin typeface="Consolas"/>
+              </a:rPr>
+              <a:t>TRANSPORT=uart</a:t>
+            </a:r>
+            <a:r>
+              <a:rPr sz="1600" b="0">
+                <a:solidFill>
+                  <a:srgbClr val="000000"/>
+                </a:solidFill>
+                <a:latin typeface="Times New Roman"/>
+              </a:rPr>
+              <a:t>; </a:t>
+            </a:r>
+            <a:r>
+              <a:rPr sz="1400" b="0">
+                <a:solidFill>
+                  <a:srgbClr val="8B1A1A"/>
+                </a:solidFill>
+                <a:latin typeface="Consolas"/>
+              </a:rPr>
+              <a:t>UART1_BAUD=&lt;baud&gt;</a:t>
+            </a:r>
+            <a:r>
+              <a:rPr sz="1600" b="0">
+                <a:solidFill>
+                  <a:srgbClr val="000000"/>
+                </a:solidFill>
+                <a:latin typeface="Times New Roman"/>
+              </a:rPr>
+              <a:t> changes the speed.</a:t>
+            </a:r>
+          </a:p>
+          <a:p>
+            <a:pPr marL="256032" indent="-219456">
+              <a:spcAft>
+                <a:spcPts val="400"/>
+              </a:spcAft>
+              <a:buChar char="•"/>
+            </a:pPr>
+            <a:r>
+              <a:rPr sz="1600" b="0">
+                <a:solidFill>
+                  <a:srgbClr val="000000"/>
+                </a:solidFill>
+                <a:latin typeface="Times New Roman"/>
+              </a:rPr>
+              <a:t>The receiver polls UART1 and is busy between frames (AEAD, SD writes), so a sender that just transmits loses bytes. The first version waited after </a:t>
+            </a:r>
+            <a:r>
+              <a:rPr sz="1600" b="1">
+                <a:solidFill>
+                  <a:srgbClr val="000000"/>
+                </a:solidFill>
+                <a:latin typeface="Times New Roman"/>
+              </a:rPr>
+              <a:t>every byte</a:t>
+            </a:r>
+            <a:r>
+              <a:rPr sz="1600" b="0">
+                <a:solidFill>
+                  <a:srgbClr val="000000"/>
+                </a:solidFill>
+                <a:latin typeface="Times New Roman"/>
+              </a:rPr>
+              <a:t>.</a:t>
+            </a:r>
+          </a:p>
+          <a:p>
+            <a:pPr marL="256032" indent="-219456">
+              <a:spcAft>
+                <a:spcPts val="400"/>
+              </a:spcAft>
+              <a:buChar char="•"/>
+            </a:pPr>
+            <a:r>
+              <a:rPr sz="1600" b="0">
+                <a:solidFill>
+                  <a:srgbClr val="000000"/>
+                </a:solidFill>
+                <a:latin typeface="Times New Roman"/>
+              </a:rPr>
+              <a:t>Now the receiver sends one READY byte every 0.2 ms while it waits for a frame; the sender drops old READYs, waits for a fresh one, then sends the frame at line rate (</a:t>
+            </a:r>
+            <a:r>
+              <a:rPr sz="1600" b="0" i="1">
+                <a:solidFill>
+                  <a:srgbClr val="000000"/>
+                </a:solidFill>
+                <a:latin typeface="Times New Roman"/>
+              </a:rPr>
+              <a:t>edhoc_transport.c</a:t>
+            </a:r>
+            <a:r>
+              <a:rPr sz="1600" b="0">
+                <a:solidFill>
+                  <a:srgbClr val="000000"/>
+                </a:solidFill>
+                <a:latin typeface="Times New Roman"/>
+              </a:rPr>
+              <a:t>). With that, the baud rate sets the pace.</a:t>
+            </a:r>
+          </a:p>
+          <a:p>
+            <a:pPr marL="256032" indent="-219456">
+              <a:spcAft>
+                <a:spcPts val="400"/>
+              </a:spcAft>
+              <a:buChar char="•"/>
+            </a:pPr>
+            <a:r>
+              <a:rPr sz="1600" b="0">
+                <a:solidFill>
+                  <a:srgbClr val="000000"/>
+                </a:solidFill>
+                <a:latin typeface="Times New Roman"/>
+              </a:rPr>
+              <a:t>Card to card, AES and the SD card now take a larger share: 5.7 s of the 32.2 s is SD access on each board.</a:t>
+            </a:r>
+          </a:p>
+        </p:txBody>
+      </p:sp>
+    </p:spTree>
+  </p:cSld>
+  <p:clrMapOvr>
+    <a:masterClrMapping/>
+  </p:clrMapOvr>
+</p:sld>
+</file>
+
+<file path=ppt/slides/slide50.xml><?xml version="1.0" encoding="utf-8"?>
 <p:sld xmlns:a="http://schemas.openxmlformats.org/drawingml/2006/main" xmlns:p="http://schemas.openxmlformats.org/presentationml/2006/main" xmlns:r="http://schemas.openxmlformats.org/officeDocument/2006/relationships">
   <p:cSld>
     <p:spTree>
@@ -31392,7 +32075,7 @@
                 <a:latin typeface="Times New Roman"/>
                 <a:ea typeface="DejaVu Sans"/>
               </a:rPr>
-              <a:t>43</a:t>
+              <a:t>44</a:t>
             </a:fld>
             <a:endParaRPr lang="en-US" sz="1600" b="0" strike="noStrike" spc="-1">
               <a:latin typeface="Arial"/>
@@ -31684,7 +32367,7 @@
 </p:sld>
 </file>
 
-<file path=ppt/slides/slide50.xml><?xml version="1.0" encoding="utf-8"?>
+<file path=ppt/slides/slide51.xml><?xml version="1.0" encoding="utf-8"?>
 <p:sld xmlns:a="http://schemas.openxmlformats.org/drawingml/2006/main" xmlns:p="http://schemas.openxmlformats.org/presentationml/2006/main" xmlns:r="http://schemas.openxmlformats.org/officeDocument/2006/relationships">
   <p:cSld>
     <p:spTree>
@@ -31817,7 +32500,7 @@
                 <a:latin typeface="Times New Roman"/>
                 <a:ea typeface="DejaVu Sans"/>
               </a:rPr>
-              <a:t>44</a:t>
+              <a:t>45</a:t>
             </a:fld>
             <a:endParaRPr lang="en-US" sz="1600" b="0" strike="noStrike" spc="-1">
               <a:latin typeface="Arial"/>
@@ -32461,7 +33144,7 @@
 </p:sld>
 </file>
 
-<file path=ppt/slides/slide51.xml><?xml version="1.0" encoding="utf-8"?>
+<file path=ppt/slides/slide52.xml><?xml version="1.0" encoding="utf-8"?>
 <p:sld xmlns:a="http://schemas.openxmlformats.org/drawingml/2006/main" xmlns:p="http://schemas.openxmlformats.org/presentationml/2006/main" xmlns:r="http://schemas.openxmlformats.org/officeDocument/2006/relationships">
   <p:cSld>
     <p:spTree>
@@ -32594,7 +33277,7 @@
                 <a:latin typeface="Times New Roman"/>
                 <a:ea typeface="DejaVu Sans"/>
               </a:rPr>
-              <a:t>45</a:t>
+              <a:t>46</a:t>
             </a:fld>
             <a:endParaRPr lang="en-US" sz="1600" b="0" strike="noStrike" spc="-1">
               <a:latin typeface="Arial"/>
@@ -32886,7 +33569,7 @@
                           </a:solidFill>
                           <a:latin typeface="Times New Roman"/>
                         </a:rPr>
-                        <a:t>the wired UART link as built is slower (2.4 KB/s); faster needs other hardware</a:t>
+                        <a:t>TRANSPORT=uart over 3 wires on PMOD JB: 32.6 KB/s card to card</a:t>
                       </a:r>
                     </a:p>
                   </a:txBody>
@@ -33113,7 +33796,7 @@
 </p:sld>
 </file>
 
-<file path=ppt/slides/slide52.xml><?xml version="1.0" encoding="utf-8"?>
+<file path=ppt/slides/slide53.xml><?xml version="1.0" encoding="utf-8"?>
 <p:sld xmlns:a="http://schemas.openxmlformats.org/drawingml/2006/main" xmlns:p="http://schemas.openxmlformats.org/presentationml/2006/main" xmlns:r="http://schemas.openxmlformats.org/officeDocument/2006/relationships">
   <p:cSld>
     <p:spTree>
@@ -33246,7 +33929,7 @@
                 <a:latin typeface="Times New Roman"/>
                 <a:ea typeface="DejaVu Sans"/>
               </a:rPr>
-              <a:t>46</a:t>
+              <a:t>47</a:t>
             </a:fld>
             <a:endParaRPr lang="en-US" sz="1600" b="0" strike="noStrike" spc="-1">
               <a:latin typeface="Arial"/>
@@ -33763,7 +34446,7 @@
 </p:sld>
 </file>
 
-<file path=ppt/slides/slide53.xml><?xml version="1.0" encoding="utf-8"?>
+<file path=ppt/slides/slide54.xml><?xml version="1.0" encoding="utf-8"?>
 <p:sld xmlns:a="http://schemas.openxmlformats.org/drawingml/2006/main" xmlns:p="http://schemas.openxmlformats.org/presentationml/2006/main" xmlns:r="http://schemas.openxmlformats.org/officeDocument/2006/relationships">
   <p:cSld>
     <p:spTree>
@@ -33949,7 +34632,7 @@
                 <a:latin typeface="Times New Roman"/>
                 <a:ea typeface="DejaVu Sans"/>
               </a:rPr>
-              <a:t>47</a:t>
+              <a:t>48</a:t>
             </a:fld>
             <a:endParaRPr lang="en-US" sz="1600" b="0" strike="noStrike" spc="-1">
               <a:latin typeface="Arial"/>
@@ -34233,458 +34916,6 @@
           </a:prstGeom>
         </p:spPr>
       </p:pic>
-    </p:spTree>
-  </p:cSld>
-  <p:clrMapOvr>
-    <a:masterClrMapping/>
-  </p:clrMapOvr>
-</p:sld>
-</file>
-
-<file path=ppt/slides/slide54.xml><?xml version="1.0" encoding="utf-8"?>
-<p:sld xmlns:a="http://schemas.openxmlformats.org/drawingml/2006/main" xmlns:p="http://schemas.openxmlformats.org/presentationml/2006/main" xmlns:r="http://schemas.openxmlformats.org/officeDocument/2006/relationships">
-  <p:cSld>
-    <p:spTree>
-      <p:nvGrpSpPr>
-        <p:cNvPr id="1" name=""/>
-        <p:cNvGrpSpPr/>
-        <p:nvPr/>
-      </p:nvGrpSpPr>
-      <p:grpSpPr/>
-      <p:sp>
-        <p:nvSpPr>
-          <p:cNvPr id="10" name="CustomShape 6">
-            <a:extLst>
-              <a:ext uri="{FF2B5EF4-FFF2-40B4-BE49-F238E27FC236}">
-                <a16:creationId xmlns:a16="http://schemas.microsoft.com/office/drawing/2014/main" id="{CB76DC60-C0C9-436D-8956-EE4CA394869E}"/>
-              </a:ext>
-            </a:extLst>
-          </p:cNvPr>
-          <p:cNvSpPr/>
-          <p:nvPr/>
-        </p:nvSpPr>
-        <p:spPr>
-          <a:xfrm>
-            <a:off x="-6000" y="0"/>
-            <a:ext cx="12198000" cy="644877"/>
-          </a:xfrm>
-          <a:prstGeom prst="rect">
-            <a:avLst/>
-          </a:prstGeom>
-          <a:solidFill>
-            <a:schemeClr val="accent6">
-              <a:lumMod val="40000"/>
-              <a:lumOff val="60000"/>
-            </a:schemeClr>
-          </a:solidFill>
-          <a:ln>
-            <a:noFill/>
-          </a:ln>
-        </p:spPr>
-        <p:style>
-          <a:lnRef idx="0">
-            <a:scrgbClr r="0" g="0" b="0"/>
-          </a:lnRef>
-          <a:fillRef idx="0">
-            <a:scrgbClr r="0" g="0" b="0"/>
-          </a:fillRef>
-          <a:effectRef idx="0">
-            <a:scrgbClr r="0" g="0" b="0"/>
-          </a:effectRef>
-          <a:fontRef idx="minor"/>
-        </p:style>
-        <p:txBody>
-          <a:bodyPr wrap="square" lIns="90000" tIns="45000" rIns="90000" bIns="45000">
-            <a:spAutoFit/>
-          </a:bodyPr>
-          <a:lstStyle/>
-          <a:p>
-            <a:pPr marL="360" algn="ctr">
-              <a:lnSpc>
-                <a:spcPct val="100000"/>
-              </a:lnSpc>
-              <a:buClr>
-                <a:srgbClr val="000000"/>
-              </a:buClr>
-            </a:pPr>
-            <a:r>
-              <a:rPr lang="en-US" sz="3600" b="1" spc="-1" dirty="0">
-                <a:latin typeface="Times New Roman" panose="02020603050405020304" pitchFamily="18" charset="0"/>
-                <a:cs typeface="Times New Roman" panose="02020603050405020304" pitchFamily="18" charset="0"/>
-              </a:rPr>
-              <a:t>7. Practice </a:t>
-            </a:r>
-            <a:r>
-              <a:rPr lang="en-US" sz="3600" spc="-1" dirty="0">
-                <a:latin typeface="Times New Roman" panose="02020603050405020304" pitchFamily="18" charset="0"/>
-                <a:cs typeface="Times New Roman" panose="02020603050405020304" pitchFamily="18" charset="0"/>
-              </a:rPr>
-              <a:t>(1/3) Exercises</a:t>
-            </a:r>
-          </a:p>
-        </p:txBody>
-      </p:sp>
-      <p:sp>
-        <p:nvSpPr>
-          <p:cNvPr id="62" name="CustomShape 2"/>
-          <p:cNvSpPr/>
-          <p:nvPr/>
-        </p:nvSpPr>
-        <p:spPr>
-          <a:xfrm>
-            <a:off x="11291400" y="6492960"/>
-            <a:ext cx="894600" cy="358920"/>
-          </a:xfrm>
-          <a:prstGeom prst="rect">
-            <a:avLst/>
-          </a:prstGeom>
-          <a:noFill/>
-          <a:ln>
-            <a:noFill/>
-          </a:ln>
-        </p:spPr>
-        <p:style>
-          <a:lnRef idx="0">
-            <a:scrgbClr r="0" g="0" b="0"/>
-          </a:lnRef>
-          <a:fillRef idx="0">
-            <a:scrgbClr r="0" g="0" b="0"/>
-          </a:fillRef>
-          <a:effectRef idx="0">
-            <a:scrgbClr r="0" g="0" b="0"/>
-          </a:effectRef>
-          <a:fontRef idx="minor"/>
-        </p:style>
-        <p:txBody>
-          <a:bodyPr lIns="90000" tIns="45000" rIns="90000" bIns="45000" anchor="ctr">
-            <a:noAutofit/>
-          </a:bodyPr>
-          <a:lstStyle/>
-          <a:p>
-            <a:pPr algn="ctr">
-              <a:lnSpc>
-                <a:spcPct val="100000"/>
-              </a:lnSpc>
-            </a:pPr>
-            <a:fld id="{32452110-F6D1-439F-92C4-7A3912DA20B0}" type="slidenum">
-              <a:rPr lang="en-US" sz="1600" b="1" strike="noStrike" spc="-1">
-                <a:solidFill>
-                  <a:srgbClr val="000000"/>
-                </a:solidFill>
-                <a:latin typeface="Times New Roman"/>
-                <a:ea typeface="DejaVu Sans"/>
-              </a:rPr>
-              <a:t>48</a:t>
-            </a:fld>
-            <a:endParaRPr lang="en-US" sz="1600" b="0" strike="noStrike" spc="-1">
-              <a:latin typeface="Arial"/>
-            </a:endParaRPr>
-          </a:p>
-        </p:txBody>
-      </p:sp>
-      <p:sp>
-        <p:nvSpPr>
-          <p:cNvPr id="63" name="Rectangle 62"/>
-          <p:cNvSpPr/>
-          <p:nvPr/>
-        </p:nvSpPr>
-        <p:spPr>
-          <a:xfrm>
-            <a:off x="365760" y="914400"/>
-            <a:ext cx="1737360" cy="411480"/>
-          </a:xfrm>
-          <a:prstGeom prst="rect">
-            <a:avLst/>
-          </a:prstGeom>
-          <a:solidFill>
-            <a:srgbClr val="FFFFFF"/>
-          </a:solidFill>
-          <a:ln>
-            <a:solidFill>
-              <a:srgbClr val="C00000"/>
-            </a:solidFill>
-          </a:ln>
-          <a:effectLst/>
-        </p:spPr>
-        <p:style>
-          <a:lnRef idx="1">
-            <a:schemeClr val="accent1"/>
-          </a:lnRef>
-          <a:fillRef idx="3">
-            <a:schemeClr val="accent1"/>
-          </a:fillRef>
-          <a:effectRef idx="2">
-            <a:schemeClr val="accent1"/>
-          </a:effectRef>
-          <a:fontRef idx="minor">
-            <a:schemeClr val="lt1"/>
-          </a:fontRef>
-        </p:style>
-        <p:txBody>
-          <a:bodyPr rtlCol="0" anchor="ctr" wrap="square" lIns="36576" rIns="36576" tIns="36576" bIns="36576"/>
-          <a:lstStyle/>
-          <a:p>
-            <a:pPr algn="ctr"/>
-            <a:r>
-              <a:rPr sz="1800" b="0">
-                <a:solidFill>
-                  <a:srgbClr val="000000"/>
-                </a:solidFill>
-                <a:latin typeface="Times New Roman"/>
-              </a:rPr>
-              <a:t>Exercise 1:</a:t>
-            </a:r>
-          </a:p>
-        </p:txBody>
-      </p:sp>
-      <p:sp>
-        <p:nvSpPr>
-          <p:cNvPr id="64" name="TextBox 63"/>
-          <p:cNvSpPr txBox="1"/>
-          <p:nvPr/>
-        </p:nvSpPr>
-        <p:spPr>
-          <a:xfrm>
-            <a:off x="457200" y="1371600"/>
-            <a:ext cx="11430000" cy="1005840"/>
-          </a:xfrm>
-          <a:prstGeom prst="rect">
-            <a:avLst/>
-          </a:prstGeom>
-          <a:noFill/>
-        </p:spPr>
-        <p:txBody>
-          <a:bodyPr wrap="square" anchor="t">
-            <a:spAutoFit/>
-          </a:bodyPr>
-          <a:lstStyle/>
-          <a:p>
-            <a:pPr marL="256032" indent="-219456">
-              <a:spcAft>
-                <a:spcPts val="400"/>
-              </a:spcAft>
-              <a:buChar char="•"/>
-            </a:pPr>
-            <a:r>
-              <a:rPr sz="1800" b="0">
-                <a:solidFill>
-                  <a:srgbClr val="000000"/>
-                </a:solidFill>
-                <a:latin typeface="Times New Roman"/>
-              </a:rPr>
-              <a:t>Send a real file (a PDF, an image) from card A to card B with TBD3. Compare the two files on a PC (sha256sum).</a:t>
-            </a:r>
-          </a:p>
-        </p:txBody>
-      </p:sp>
-      <p:sp>
-        <p:nvSpPr>
-          <p:cNvPr id="65" name="Rectangle 64"/>
-          <p:cNvSpPr/>
-          <p:nvPr/>
-        </p:nvSpPr>
-        <p:spPr>
-          <a:xfrm>
-            <a:off x="365760" y="2377440"/>
-            <a:ext cx="1737360" cy="411480"/>
-          </a:xfrm>
-          <a:prstGeom prst="rect">
-            <a:avLst/>
-          </a:prstGeom>
-          <a:solidFill>
-            <a:srgbClr val="FFFFFF"/>
-          </a:solidFill>
-          <a:ln>
-            <a:solidFill>
-              <a:srgbClr val="C00000"/>
-            </a:solidFill>
-          </a:ln>
-          <a:effectLst/>
-        </p:spPr>
-        <p:style>
-          <a:lnRef idx="1">
-            <a:schemeClr val="accent1"/>
-          </a:lnRef>
-          <a:fillRef idx="3">
-            <a:schemeClr val="accent1"/>
-          </a:fillRef>
-          <a:effectRef idx="2">
-            <a:schemeClr val="accent1"/>
-          </a:effectRef>
-          <a:fontRef idx="minor">
-            <a:schemeClr val="lt1"/>
-          </a:fontRef>
-        </p:style>
-        <p:txBody>
-          <a:bodyPr rtlCol="0" anchor="ctr" wrap="square" lIns="36576" rIns="36576" tIns="36576" bIns="36576"/>
-          <a:lstStyle/>
-          <a:p>
-            <a:pPr algn="ctr"/>
-            <a:r>
-              <a:rPr sz="1800" b="0">
-                <a:solidFill>
-                  <a:srgbClr val="000000"/>
-                </a:solidFill>
-                <a:latin typeface="Times New Roman"/>
-              </a:rPr>
-              <a:t>Exercise 2:</a:t>
-            </a:r>
-          </a:p>
-        </p:txBody>
-      </p:sp>
-      <p:sp>
-        <p:nvSpPr>
-          <p:cNvPr id="66" name="TextBox 65"/>
-          <p:cNvSpPr txBox="1"/>
-          <p:nvPr/>
-        </p:nvSpPr>
-        <p:spPr>
-          <a:xfrm>
-            <a:off x="457200" y="2834640"/>
-            <a:ext cx="11430000" cy="1005840"/>
-          </a:xfrm>
-          <a:prstGeom prst="rect">
-            <a:avLst/>
-          </a:prstGeom>
-          <a:noFill/>
-        </p:spPr>
-        <p:txBody>
-          <a:bodyPr wrap="square" anchor="t">
-            <a:spAutoFit/>
-          </a:bodyPr>
-          <a:lstStyle/>
-          <a:p>
-            <a:pPr marL="256032" indent="-219456">
-              <a:spcAft>
-                <a:spcPts val="400"/>
-              </a:spcAft>
-              <a:buChar char="•"/>
-            </a:pPr>
-            <a:r>
-              <a:rPr sz="1800" b="0">
-                <a:solidFill>
-                  <a:srgbClr val="000000"/>
-                </a:solidFill>
-                <a:latin typeface="Times New Roman"/>
-              </a:rPr>
-              <a:t>Build the radio link without the CRC (remove </a:t>
-            </a:r>
-            <a:r>
-              <a:rPr sz="1600" b="0">
-                <a:solidFill>
-                  <a:srgbClr val="8B1A1A"/>
-                </a:solidFill>
-                <a:latin typeface="Consolas"/>
-              </a:rPr>
-              <a:t>seal</a:t>
-            </a:r>
-            <a:r>
-              <a:rPr sz="1800" b="0">
-                <a:solidFill>
-                  <a:srgbClr val="000000"/>
-                </a:solidFill>
-                <a:latin typeface="Times New Roman"/>
-              </a:rPr>
-              <a:t> and the check). Stream 1 MiB. What fails, after how long? Restore the file afterwards.</a:t>
-            </a:r>
-          </a:p>
-        </p:txBody>
-      </p:sp>
-      <p:sp>
-        <p:nvSpPr>
-          <p:cNvPr id="67" name="Rectangle 66"/>
-          <p:cNvSpPr/>
-          <p:nvPr/>
-        </p:nvSpPr>
-        <p:spPr>
-          <a:xfrm>
-            <a:off x="365760" y="3840480"/>
-            <a:ext cx="1737360" cy="411480"/>
-          </a:xfrm>
-          <a:prstGeom prst="rect">
-            <a:avLst/>
-          </a:prstGeom>
-          <a:solidFill>
-            <a:srgbClr val="FFFFFF"/>
-          </a:solidFill>
-          <a:ln>
-            <a:solidFill>
-              <a:srgbClr val="C00000"/>
-            </a:solidFill>
-          </a:ln>
-          <a:effectLst/>
-        </p:spPr>
-        <p:style>
-          <a:lnRef idx="1">
-            <a:schemeClr val="accent1"/>
-          </a:lnRef>
-          <a:fillRef idx="3">
-            <a:schemeClr val="accent1"/>
-          </a:fillRef>
-          <a:effectRef idx="2">
-            <a:schemeClr val="accent1"/>
-          </a:effectRef>
-          <a:fontRef idx="minor">
-            <a:schemeClr val="lt1"/>
-          </a:fontRef>
-        </p:style>
-        <p:txBody>
-          <a:bodyPr rtlCol="0" anchor="ctr" wrap="square" lIns="36576" rIns="36576" tIns="36576" bIns="36576"/>
-          <a:lstStyle/>
-          <a:p>
-            <a:pPr algn="ctr"/>
-            <a:r>
-              <a:rPr sz="1800" b="0">
-                <a:solidFill>
-                  <a:srgbClr val="000000"/>
-                </a:solidFill>
-                <a:latin typeface="Times New Roman"/>
-              </a:rPr>
-              <a:t>Exercise 3:</a:t>
-            </a:r>
-          </a:p>
-        </p:txBody>
-      </p:sp>
-      <p:sp>
-        <p:nvSpPr>
-          <p:cNvPr id="68" name="TextBox 67"/>
-          <p:cNvSpPr txBox="1"/>
-          <p:nvPr/>
-        </p:nvSpPr>
-        <p:spPr>
-          <a:xfrm>
-            <a:off x="457200" y="4297680"/>
-            <a:ext cx="11430000" cy="1005840"/>
-          </a:xfrm>
-          <a:prstGeom prst="rect">
-            <a:avLst/>
-          </a:prstGeom>
-          <a:noFill/>
-        </p:spPr>
-        <p:txBody>
-          <a:bodyPr wrap="square" anchor="t">
-            <a:spAutoFit/>
-          </a:bodyPr>
-          <a:lstStyle/>
-          <a:p>
-            <a:pPr marL="256032" indent="-219456">
-              <a:spcAft>
-                <a:spcPts val="400"/>
-              </a:spcAft>
-              <a:buChar char="•"/>
-            </a:pPr>
-            <a:r>
-              <a:rPr sz="1800" b="0">
-                <a:solidFill>
-                  <a:srgbClr val="000000"/>
-                </a:solidFill>
-                <a:latin typeface="Times New Roman"/>
-              </a:rPr>
-              <a:t>Measure KB/s for 64 KiB, 256 KiB and 1 MiB. Is the speed constant? Estimate the time for 100 MB.</a:t>
-            </a:r>
-          </a:p>
-        </p:txBody>
-      </p:sp>
     </p:spTree>
   </p:cSld>
   <p:clrMapOvr>
@@ -34771,7 +35002,7 @@
                 <a:latin typeface="Times New Roman" panose="02020603050405020304" pitchFamily="18" charset="0"/>
                 <a:cs typeface="Times New Roman" panose="02020603050405020304" pitchFamily="18" charset="0"/>
               </a:rPr>
-              <a:t>(2/3) What to put in the report</a:t>
+              <a:t>(1/3) Exercises</a:t>
             </a:r>
           </a:p>
         </p:txBody>
@@ -34836,14 +35067,69 @@
       </p:sp>
       <p:sp>
         <p:nvSpPr>
-          <p:cNvPr id="63" name="TextBox 62"/>
+          <p:cNvPr id="63" name="Rectangle 62"/>
+          <p:cNvSpPr/>
+          <p:nvPr/>
+        </p:nvSpPr>
+        <p:spPr>
+          <a:xfrm>
+            <a:off x="365760" y="914400"/>
+            <a:ext cx="1737360" cy="411480"/>
+          </a:xfrm>
+          <a:prstGeom prst="rect">
+            <a:avLst/>
+          </a:prstGeom>
+          <a:solidFill>
+            <a:srgbClr val="FFFFFF"/>
+          </a:solidFill>
+          <a:ln>
+            <a:solidFill>
+              <a:srgbClr val="C00000"/>
+            </a:solidFill>
+          </a:ln>
+          <a:effectLst/>
+        </p:spPr>
+        <p:style>
+          <a:lnRef idx="1">
+            <a:schemeClr val="accent1"/>
+          </a:lnRef>
+          <a:fillRef idx="3">
+            <a:schemeClr val="accent1"/>
+          </a:fillRef>
+          <a:effectRef idx="2">
+            <a:schemeClr val="accent1"/>
+          </a:effectRef>
+          <a:fontRef idx="minor">
+            <a:schemeClr val="lt1"/>
+          </a:fontRef>
+        </p:style>
+        <p:txBody>
+          <a:bodyPr rtlCol="0" anchor="ctr" wrap="square" lIns="36576" rIns="36576" tIns="36576" bIns="36576"/>
+          <a:lstStyle/>
+          <a:p>
+            <a:pPr algn="ctr"/>
+            <a:r>
+              <a:rPr sz="1800" b="0">
+                <a:solidFill>
+                  <a:srgbClr val="000000"/>
+                </a:solidFill>
+                <a:latin typeface="Times New Roman"/>
+              </a:rPr>
+              <a:t>Exercise 1:</a:t>
+            </a:r>
+          </a:p>
+        </p:txBody>
+      </p:sp>
+      <p:sp>
+        <p:nvSpPr>
+          <p:cNvPr id="64" name="TextBox 63"/>
           <p:cNvSpPr txBox="1"/>
           <p:nvPr/>
         </p:nvSpPr>
         <p:spPr>
           <a:xfrm>
-            <a:off x="457200" y="1005840"/>
-            <a:ext cx="11247120" cy="4572000"/>
+            <a:off x="457200" y="1371600"/>
+            <a:ext cx="11430000" cy="1005840"/>
           </a:xfrm>
           <a:prstGeom prst="rect">
             <a:avLst/>
@@ -34863,15 +35149,93 @@
               <a:buChar char="•"/>
             </a:pPr>
             <a:r>
-              <a:rPr sz="2000" b="0">
+              <a:rPr sz="1800" b="0">
                 <a:solidFill>
                   <a:srgbClr val="000000"/>
                 </a:solidFill>
                 <a:latin typeface="Times New Roman"/>
               </a:rPr>
-              <a:t>Exercise 1: both consoles, the two sha256 values, the time and KB/s.</a:t>
-            </a:r>
-          </a:p>
+              <a:t>Send a real file (a PDF, an image) from card A to card B with TBD3. Compare the two files on a PC (sha256sum).</a:t>
+            </a:r>
+          </a:p>
+        </p:txBody>
+      </p:sp>
+      <p:sp>
+        <p:nvSpPr>
+          <p:cNvPr id="65" name="Rectangle 64"/>
+          <p:cNvSpPr/>
+          <p:nvPr/>
+        </p:nvSpPr>
+        <p:spPr>
+          <a:xfrm>
+            <a:off x="365760" y="2377440"/>
+            <a:ext cx="1737360" cy="411480"/>
+          </a:xfrm>
+          <a:prstGeom prst="rect">
+            <a:avLst/>
+          </a:prstGeom>
+          <a:solidFill>
+            <a:srgbClr val="FFFFFF"/>
+          </a:solidFill>
+          <a:ln>
+            <a:solidFill>
+              <a:srgbClr val="C00000"/>
+            </a:solidFill>
+          </a:ln>
+          <a:effectLst/>
+        </p:spPr>
+        <p:style>
+          <a:lnRef idx="1">
+            <a:schemeClr val="accent1"/>
+          </a:lnRef>
+          <a:fillRef idx="3">
+            <a:schemeClr val="accent1"/>
+          </a:fillRef>
+          <a:effectRef idx="2">
+            <a:schemeClr val="accent1"/>
+          </a:effectRef>
+          <a:fontRef idx="minor">
+            <a:schemeClr val="lt1"/>
+          </a:fontRef>
+        </p:style>
+        <p:txBody>
+          <a:bodyPr rtlCol="0" anchor="ctr" wrap="square" lIns="36576" rIns="36576" tIns="36576" bIns="36576"/>
+          <a:lstStyle/>
+          <a:p>
+            <a:pPr algn="ctr"/>
+            <a:r>
+              <a:rPr sz="1800" b="0">
+                <a:solidFill>
+                  <a:srgbClr val="000000"/>
+                </a:solidFill>
+                <a:latin typeface="Times New Roman"/>
+              </a:rPr>
+              <a:t>Exercise 2:</a:t>
+            </a:r>
+          </a:p>
+        </p:txBody>
+      </p:sp>
+      <p:sp>
+        <p:nvSpPr>
+          <p:cNvPr id="66" name="TextBox 65"/>
+          <p:cNvSpPr txBox="1"/>
+          <p:nvPr/>
+        </p:nvSpPr>
+        <p:spPr>
+          <a:xfrm>
+            <a:off x="457200" y="2834640"/>
+            <a:ext cx="11430000" cy="1005840"/>
+          </a:xfrm>
+          <a:prstGeom prst="rect">
+            <a:avLst/>
+          </a:prstGeom>
+          <a:noFill/>
+        </p:spPr>
+        <p:txBody>
+          <a:bodyPr wrap="square" anchor="t">
+            <a:spAutoFit/>
+          </a:bodyPr>
+          <a:lstStyle/>
           <a:p>
             <a:pPr marL="256032" indent="-219456">
               <a:spcAft>
@@ -34880,15 +35244,111 @@
               <a:buChar char="•"/>
             </a:pPr>
             <a:r>
-              <a:rPr sz="2000" b="0">
+              <a:rPr sz="1800" b="0">
                 <a:solidFill>
                   <a:srgbClr val="000000"/>
                 </a:solidFill>
                 <a:latin typeface="Times New Roman"/>
               </a:rPr>
-              <a:t>Exercise 2: the console at the failure and your explanation.</a:t>
-            </a:r>
-          </a:p>
+              <a:t>Build the radio link without the CRC (remove </a:t>
+            </a:r>
+            <a:r>
+              <a:rPr sz="1600" b="0">
+                <a:solidFill>
+                  <a:srgbClr val="8B1A1A"/>
+                </a:solidFill>
+                <a:latin typeface="Consolas"/>
+              </a:rPr>
+              <a:t>seal</a:t>
+            </a:r>
+            <a:r>
+              <a:rPr sz="1800" b="0">
+                <a:solidFill>
+                  <a:srgbClr val="000000"/>
+                </a:solidFill>
+                <a:latin typeface="Times New Roman"/>
+              </a:rPr>
+              <a:t> and the check). Stream 1 MiB. What fails, after how long? Restore the file afterwards.</a:t>
+            </a:r>
+          </a:p>
+        </p:txBody>
+      </p:sp>
+      <p:sp>
+        <p:nvSpPr>
+          <p:cNvPr id="67" name="Rectangle 66"/>
+          <p:cNvSpPr/>
+          <p:nvPr/>
+        </p:nvSpPr>
+        <p:spPr>
+          <a:xfrm>
+            <a:off x="365760" y="3840480"/>
+            <a:ext cx="1737360" cy="411480"/>
+          </a:xfrm>
+          <a:prstGeom prst="rect">
+            <a:avLst/>
+          </a:prstGeom>
+          <a:solidFill>
+            <a:srgbClr val="FFFFFF"/>
+          </a:solidFill>
+          <a:ln>
+            <a:solidFill>
+              <a:srgbClr val="C00000"/>
+            </a:solidFill>
+          </a:ln>
+          <a:effectLst/>
+        </p:spPr>
+        <p:style>
+          <a:lnRef idx="1">
+            <a:schemeClr val="accent1"/>
+          </a:lnRef>
+          <a:fillRef idx="3">
+            <a:schemeClr val="accent1"/>
+          </a:fillRef>
+          <a:effectRef idx="2">
+            <a:schemeClr val="accent1"/>
+          </a:effectRef>
+          <a:fontRef idx="minor">
+            <a:schemeClr val="lt1"/>
+          </a:fontRef>
+        </p:style>
+        <p:txBody>
+          <a:bodyPr rtlCol="0" anchor="ctr" wrap="square" lIns="36576" rIns="36576" tIns="36576" bIns="36576"/>
+          <a:lstStyle/>
+          <a:p>
+            <a:pPr algn="ctr"/>
+            <a:r>
+              <a:rPr sz="1800" b="0">
+                <a:solidFill>
+                  <a:srgbClr val="000000"/>
+                </a:solidFill>
+                <a:latin typeface="Times New Roman"/>
+              </a:rPr>
+              <a:t>Exercise 3:</a:t>
+            </a:r>
+          </a:p>
+        </p:txBody>
+      </p:sp>
+      <p:sp>
+        <p:nvSpPr>
+          <p:cNvPr id="68" name="TextBox 67"/>
+          <p:cNvSpPr txBox="1"/>
+          <p:nvPr/>
+        </p:nvSpPr>
+        <p:spPr>
+          <a:xfrm>
+            <a:off x="457200" y="4297680"/>
+            <a:ext cx="11430000" cy="1005840"/>
+          </a:xfrm>
+          <a:prstGeom prst="rect">
+            <a:avLst/>
+          </a:prstGeom>
+          <a:noFill/>
+        </p:spPr>
+        <p:txBody>
+          <a:bodyPr wrap="square" anchor="t">
+            <a:spAutoFit/>
+          </a:bodyPr>
+          <a:lstStyle/>
           <a:p>
             <a:pPr marL="256032" indent="-219456">
               <a:spcAft>
@@ -34897,13 +35357,13 @@
               <a:buChar char="•"/>
             </a:pPr>
             <a:r>
-              <a:rPr sz="2000" b="0">
+              <a:rPr sz="1800" b="0">
                 <a:solidFill>
                   <a:srgbClr val="000000"/>
                 </a:solidFill>
                 <a:latin typeface="Times New Roman"/>
               </a:rPr>
-              <a:t>Exercise 3: a table and a chart of size vs. time; your 100 MB estimate.</a:t>
+              <a:t>Measure KB/s for 64 KiB, 256 KiB and 1 MiB. Is the speed constant? Estimate the time for 100 MB.</a:t>
             </a:r>
           </a:p>
         </p:txBody>
@@ -34994,7 +35454,7 @@
                 <a:latin typeface="Times New Roman" panose="02020603050405020304" pitchFamily="18" charset="0"/>
                 <a:cs typeface="Times New Roman" panose="02020603050405020304" pitchFamily="18" charset="0"/>
               </a:rPr>
-              <a:t>(3/3) Answer notes</a:t>
+              <a:t>(2/3) What to put in the report</a:t>
             </a:r>
           </a:p>
         </p:txBody>
@@ -35050,6 +35510,229 @@
                 <a:ea typeface="DejaVu Sans"/>
               </a:rPr>
               <a:t>50</a:t>
+            </a:fld>
+            <a:endParaRPr lang="en-US" sz="1600" b="0" strike="noStrike" spc="-1">
+              <a:latin typeface="Arial"/>
+            </a:endParaRPr>
+          </a:p>
+        </p:txBody>
+      </p:sp>
+      <p:sp>
+        <p:nvSpPr>
+          <p:cNvPr id="63" name="TextBox 62"/>
+          <p:cNvSpPr txBox="1"/>
+          <p:nvPr/>
+        </p:nvSpPr>
+        <p:spPr>
+          <a:xfrm>
+            <a:off x="457200" y="1005840"/>
+            <a:ext cx="11247120" cy="4572000"/>
+          </a:xfrm>
+          <a:prstGeom prst="rect">
+            <a:avLst/>
+          </a:prstGeom>
+          <a:noFill/>
+        </p:spPr>
+        <p:txBody>
+          <a:bodyPr wrap="square" anchor="t">
+            <a:spAutoFit/>
+          </a:bodyPr>
+          <a:lstStyle/>
+          <a:p>
+            <a:pPr marL="256032" indent="-219456">
+              <a:spcAft>
+                <a:spcPts val="400"/>
+              </a:spcAft>
+              <a:buChar char="•"/>
+            </a:pPr>
+            <a:r>
+              <a:rPr sz="2000" b="0">
+                <a:solidFill>
+                  <a:srgbClr val="000000"/>
+                </a:solidFill>
+                <a:latin typeface="Times New Roman"/>
+              </a:rPr>
+              <a:t>Exercise 1: both consoles, the two sha256 values, the time and KB/s.</a:t>
+            </a:r>
+          </a:p>
+          <a:p>
+            <a:pPr marL="256032" indent="-219456">
+              <a:spcAft>
+                <a:spcPts val="400"/>
+              </a:spcAft>
+              <a:buChar char="•"/>
+            </a:pPr>
+            <a:r>
+              <a:rPr sz="2000" b="0">
+                <a:solidFill>
+                  <a:srgbClr val="000000"/>
+                </a:solidFill>
+                <a:latin typeface="Times New Roman"/>
+              </a:rPr>
+              <a:t>Exercise 2: the console at the failure and your explanation.</a:t>
+            </a:r>
+          </a:p>
+          <a:p>
+            <a:pPr marL="256032" indent="-219456">
+              <a:spcAft>
+                <a:spcPts val="400"/>
+              </a:spcAft>
+              <a:buChar char="•"/>
+            </a:pPr>
+            <a:r>
+              <a:rPr sz="2000" b="0">
+                <a:solidFill>
+                  <a:srgbClr val="000000"/>
+                </a:solidFill>
+                <a:latin typeface="Times New Roman"/>
+              </a:rPr>
+              <a:t>Exercise 3: a table and a chart of size vs. time; your 100 MB estimate.</a:t>
+            </a:r>
+          </a:p>
+        </p:txBody>
+      </p:sp>
+    </p:spTree>
+  </p:cSld>
+  <p:clrMapOvr>
+    <a:masterClrMapping/>
+  </p:clrMapOvr>
+</p:sld>
+</file>
+
+<file path=ppt/slides/slide57.xml><?xml version="1.0" encoding="utf-8"?>
+<p:sld xmlns:a="http://schemas.openxmlformats.org/drawingml/2006/main" xmlns:p="http://schemas.openxmlformats.org/presentationml/2006/main" xmlns:r="http://schemas.openxmlformats.org/officeDocument/2006/relationships">
+  <p:cSld>
+    <p:spTree>
+      <p:nvGrpSpPr>
+        <p:cNvPr id="1" name=""/>
+        <p:cNvGrpSpPr/>
+        <p:nvPr/>
+      </p:nvGrpSpPr>
+      <p:grpSpPr/>
+      <p:sp>
+        <p:nvSpPr>
+          <p:cNvPr id="10" name="CustomShape 6">
+            <a:extLst>
+              <a:ext uri="{FF2B5EF4-FFF2-40B4-BE49-F238E27FC236}">
+                <a16:creationId xmlns:a16="http://schemas.microsoft.com/office/drawing/2014/main" id="{CB76DC60-C0C9-436D-8956-EE4CA394869E}"/>
+              </a:ext>
+            </a:extLst>
+          </p:cNvPr>
+          <p:cNvSpPr/>
+          <p:nvPr/>
+        </p:nvSpPr>
+        <p:spPr>
+          <a:xfrm>
+            <a:off x="-6000" y="0"/>
+            <a:ext cx="12198000" cy="644877"/>
+          </a:xfrm>
+          <a:prstGeom prst="rect">
+            <a:avLst/>
+          </a:prstGeom>
+          <a:solidFill>
+            <a:schemeClr val="accent6">
+              <a:lumMod val="40000"/>
+              <a:lumOff val="60000"/>
+            </a:schemeClr>
+          </a:solidFill>
+          <a:ln>
+            <a:noFill/>
+          </a:ln>
+        </p:spPr>
+        <p:style>
+          <a:lnRef idx="0">
+            <a:scrgbClr r="0" g="0" b="0"/>
+          </a:lnRef>
+          <a:fillRef idx="0">
+            <a:scrgbClr r="0" g="0" b="0"/>
+          </a:fillRef>
+          <a:effectRef idx="0">
+            <a:scrgbClr r="0" g="0" b="0"/>
+          </a:effectRef>
+          <a:fontRef idx="minor"/>
+        </p:style>
+        <p:txBody>
+          <a:bodyPr wrap="square" lIns="90000" tIns="45000" rIns="90000" bIns="45000">
+            <a:spAutoFit/>
+          </a:bodyPr>
+          <a:lstStyle/>
+          <a:p>
+            <a:pPr marL="360" algn="ctr">
+              <a:lnSpc>
+                <a:spcPct val="100000"/>
+              </a:lnSpc>
+              <a:buClr>
+                <a:srgbClr val="000000"/>
+              </a:buClr>
+            </a:pPr>
+            <a:r>
+              <a:rPr lang="en-US" sz="3600" b="1" spc="-1" dirty="0">
+                <a:latin typeface="Times New Roman" panose="02020603050405020304" pitchFamily="18" charset="0"/>
+                <a:cs typeface="Times New Roman" panose="02020603050405020304" pitchFamily="18" charset="0"/>
+              </a:rPr>
+              <a:t>7. Practice </a:t>
+            </a:r>
+            <a:r>
+              <a:rPr lang="en-US" sz="3600" spc="-1" dirty="0">
+                <a:latin typeface="Times New Roman" panose="02020603050405020304" pitchFamily="18" charset="0"/>
+                <a:cs typeface="Times New Roman" panose="02020603050405020304" pitchFamily="18" charset="0"/>
+              </a:rPr>
+              <a:t>(3/3) Answer notes</a:t>
+            </a:r>
+          </a:p>
+        </p:txBody>
+      </p:sp>
+      <p:sp>
+        <p:nvSpPr>
+          <p:cNvPr id="62" name="CustomShape 2"/>
+          <p:cNvSpPr/>
+          <p:nvPr/>
+        </p:nvSpPr>
+        <p:spPr>
+          <a:xfrm>
+            <a:off x="11291400" y="6492960"/>
+            <a:ext cx="894600" cy="358920"/>
+          </a:xfrm>
+          <a:prstGeom prst="rect">
+            <a:avLst/>
+          </a:prstGeom>
+          <a:noFill/>
+          <a:ln>
+            <a:noFill/>
+          </a:ln>
+        </p:spPr>
+        <p:style>
+          <a:lnRef idx="0">
+            <a:scrgbClr r="0" g="0" b="0"/>
+          </a:lnRef>
+          <a:fillRef idx="0">
+            <a:scrgbClr r="0" g="0" b="0"/>
+          </a:fillRef>
+          <a:effectRef idx="0">
+            <a:scrgbClr r="0" g="0" b="0"/>
+          </a:effectRef>
+          <a:fontRef idx="minor"/>
+        </p:style>
+        <p:txBody>
+          <a:bodyPr lIns="90000" tIns="45000" rIns="90000" bIns="45000" anchor="ctr">
+            <a:noAutofit/>
+          </a:bodyPr>
+          <a:lstStyle/>
+          <a:p>
+            <a:pPr algn="ctr">
+              <a:lnSpc>
+                <a:spcPct val="100000"/>
+              </a:lnSpc>
+            </a:pPr>
+            <a:fld id="{32452110-F6D1-439F-92C4-7A3912DA20B0}" type="slidenum">
+              <a:rPr lang="en-US" sz="1600" b="1" strike="noStrike" spc="-1">
+                <a:solidFill>
+                  <a:srgbClr val="000000"/>
+                </a:solidFill>
+                <a:latin typeface="Times New Roman"/>
+                <a:ea typeface="DejaVu Sans"/>
+              </a:rPr>
+              <a:t>51</a:t>
             </a:fld>
             <a:endParaRPr lang="en-US" sz="1600" b="0" strike="noStrike" spc="-1">
               <a:latin typeface="Arial"/>
@@ -35457,7 +36140,7 @@
 </p:sld>
 </file>
 
-<file path=ppt/slides/slide57.xml><?xml version="1.0" encoding="utf-8"?>
+<file path=ppt/slides/slide58.xml><?xml version="1.0" encoding="utf-8"?>
 <p:sld xmlns:a="http://schemas.openxmlformats.org/drawingml/2006/main" xmlns:p="http://schemas.openxmlformats.org/presentationml/2006/main" xmlns:r="http://schemas.openxmlformats.org/officeDocument/2006/relationships">
   <p:cSld>
     <p:spTree>
@@ -35585,7 +36268,7 @@
                 <a:latin typeface="Times New Roman"/>
                 <a:ea typeface="DejaVu Sans"/>
               </a:rPr>
-              <a:t>51</a:t>
+              <a:t>52</a:t>
             </a:fld>
             <a:endParaRPr lang="en-US" sz="1600" b="0" strike="noStrike" spc="-1">
               <a:latin typeface="Arial"/>
@@ -35826,7 +36509,7 @@
 </p:sld>
 </file>
 
-<file path=ppt/slides/slide58.xml><?xml version="1.0" encoding="utf-8"?>
+<file path=ppt/slides/slide59.xml><?xml version="1.0" encoding="utf-8"?>
 <p:sld xmlns:a="http://schemas.openxmlformats.org/drawingml/2006/main" xmlns:p="http://schemas.openxmlformats.org/presentationml/2006/main" xmlns:r="http://schemas.openxmlformats.org/officeDocument/2006/relationships">
   <p:cSld>
     <p:spTree>
@@ -35990,7 +36673,7 @@
                 <a:latin typeface="Times New Roman"/>
                 <a:ea typeface="DejaVu Sans"/>
               </a:rPr>
-              <a:t>52</a:t>
+              <a:t>53</a:t>
             </a:fld>
             <a:endParaRPr lang="en-US" sz="1600" b="0" strike="noStrike" spc="-1">
               <a:latin typeface="Arial"/>
@@ -36983,7 +37666,7 @@
                 </a:solidFill>
                 <a:latin typeface="Times New Roman"/>
               </a:rPr>
-              <a:t>Measure where the time goes, make it faster, and see how each question behind the project was answered.</a:t>
+              <a:t>Measure where the time goes, make it faster (radio, then a 3× faster wired link), and see how each question behind the project was answered.</a:t>
             </a:r>
           </a:p>
           <a:p>

</xml_diff>